<commit_message>
docs: tighten "Was ist EasyPilot iOS" wording
Drop the 4AHITM/drone line and the "mobile Co-Pilot" framing; use direct
statements (auto-connect over WLAN, live telemetry + 3D simulator, and — on the
standard deck — stabilization/helper algorithms controllable via the app).

Co-Authored-By: Claude Opus 4.8 <noreply@anthropic.com>
</commit_message>
<xml_diff>
--- a/docs/presentation-ios/EasyPilot-iOS-Extended.pptx
+++ b/docs/presentation-ios/EasyPilot-iOS-Extended.pptx
@@ -4390,7 +4390,7 @@
         </p:nvSpPr>
         <p:spPr>
           <a:xfrm>
-            <a:off x="868680" y="3273551"/>
+            <a:off x="868680" y="3410712"/>
             <a:ext cx="54864" cy="566928"/>
           </a:xfrm>
           <a:prstGeom prst="rect">
@@ -4434,7 +4434,7 @@
         </p:nvSpPr>
         <p:spPr>
           <a:xfrm>
-            <a:off x="1188720" y="3246120"/>
+            <a:off x="1188720" y="3383280"/>
             <a:ext cx="6766560" cy="1371600"/>
           </a:xfrm>
           <a:prstGeom prst="rect">
@@ -4466,7 +4466,7 @@
                 </a:solidFill>
                 <a:latin typeface="Segoe UI"/>
               </a:rPr>
-              <a:t>EasyPilot ist unser Drohnenprojekt der 4AHITM – eine handelsübliche Drohne, die wir mit einem ESP32 erweitert haben.</a:t>
+              <a:t>Verbindet sich von selbst über das WLAN mit der Drohne – ohne Eingabe einer IP-Adresse.</a:t>
             </a:r>
           </a:p>
         </p:txBody>
@@ -4479,8 +4479,8 @@
         </p:nvSpPr>
         <p:spPr>
           <a:xfrm>
-            <a:off x="868680" y="4251960"/>
-            <a:ext cx="54864" cy="777240"/>
+            <a:off x="868680" y="4599432"/>
+            <a:ext cx="54864" cy="566928"/>
           </a:xfrm>
           <a:prstGeom prst="rect">
             <a:avLst/>
@@ -4523,7 +4523,7 @@
         </p:nvSpPr>
         <p:spPr>
           <a:xfrm>
-            <a:off x="1188720" y="4224528"/>
+            <a:off x="1188720" y="4572000"/>
             <a:ext cx="6766560" cy="1371600"/>
           </a:xfrm>
           <a:prstGeom prst="rect">
@@ -4555,96 +4555,7 @@
                 </a:solidFill>
                 <a:latin typeface="Segoe UI"/>
               </a:rPr>
-              <a:t>Die iOS-App ist der mobile Co-Pilot: Sie verbindet sich von selbst über das WLAN mit der Drohne, ganz ohne Eingabe einer IP-Adresse.</a:t>
-            </a:r>
-          </a:p>
-        </p:txBody>
-      </p:sp>
-      <p:sp>
-        <p:nvSpPr>
-          <p:cNvPr id="13" name="Rectangle 12"/>
-          <p:cNvSpPr/>
-          <p:nvPr/>
-        </p:nvSpPr>
-        <p:spPr>
-          <a:xfrm>
-            <a:off x="868680" y="5376672"/>
-            <a:ext cx="54864" cy="868680"/>
-          </a:xfrm>
-          <a:prstGeom prst="rect">
-            <a:avLst/>
-          </a:prstGeom>
-          <a:solidFill>
-            <a:srgbClr val="2F80ED"/>
-          </a:solidFill>
-          <a:ln>
-            <a:noFill/>
-          </a:ln>
-          <a:effectLst/>
-        </p:spPr>
-        <p:style>
-          <a:lnRef idx="1">
-            <a:schemeClr val="accent1"/>
-          </a:lnRef>
-          <a:fillRef idx="3">
-            <a:schemeClr val="accent1"/>
-          </a:fillRef>
-          <a:effectRef idx="2">
-            <a:schemeClr val="accent1"/>
-          </a:effectRef>
-          <a:fontRef idx="minor">
-            <a:schemeClr val="lt1"/>
-          </a:fontRef>
-        </p:style>
-        <p:txBody>
-          <a:bodyPr rtlCol="0" anchor="ctr"/>
-          <a:lstStyle/>
-          <a:p>
-            <a:pPr algn="ctr"/>
-          </a:p>
-        </p:txBody>
-      </p:sp>
-      <p:sp>
-        <p:nvSpPr>
-          <p:cNvPr id="14" name="TextBox 13"/>
-          <p:cNvSpPr txBox="1"/>
-          <p:nvPr/>
-        </p:nvSpPr>
-        <p:spPr>
-          <a:xfrm>
-            <a:off x="1188720" y="5349240"/>
-            <a:ext cx="6766560" cy="1371600"/>
-          </a:xfrm>
-          <a:prstGeom prst="rect">
-            <a:avLst/>
-          </a:prstGeom>
-          <a:noFill/>
-        </p:spPr>
-        <p:txBody>
-          <a:bodyPr wrap="square" anchor="t" lIns="0" rIns="0" tIns="0" bIns="0">
-            <a:spAutoFit/>
-          </a:bodyPr>
-          <a:lstStyle/>
-          <a:p>
-            <a:pPr algn="l">
-              <a:lnSpc>
-                <a:spcPct val="116000"/>
-              </a:lnSpc>
-              <a:spcBef>
-                <a:spcPts val="0"/>
-              </a:spcBef>
-              <a:spcAft>
-                <a:spcPts val="800"/>
-              </a:spcAft>
-            </a:pPr>
-            <a:r>
-              <a:rPr sz="1650" b="0">
-                <a:solidFill>
-                  <a:srgbClr val="2B3340"/>
-                </a:solidFill>
-                <a:latin typeface="Segoe UI"/>
-              </a:rPr>
-              <a:t>Sobald die Verbindung steht, zeigt sie die Telemetrie zehnmal pro Sekunde in Echtzeit an und bringt einen eigenen 3D-Flugsimulator direkt aufs Handy. Gebaut ist alles in SwiftUI – nur mit Apple-eigenen Frameworks.</a:t>
+              <a:t>Zeigt die Telemetrie zehnmal pro Sekunde in Echtzeit an und bringt einen eigenen 3D-Flugsimulator direkt aufs Handy.</a:t>
             </a:r>
           </a:p>
         </p:txBody>

</xml_diff>

<commit_message>
docs: replace title kicker with a small tagline heading
Title slide now leads with "Das iPhone wird zur Anzeige- und Steuerzentrale
für unsere Drohne." instead of the EASYPILOT/4AHITM kicker.

Co-Authored-By: Claude Opus 4.8 <noreply@anthropic.com>
</commit_message>
<xml_diff>
--- a/docs/presentation-ios/EasyPilot-iOS-Extended.pptx
+++ b/docs/presentation-ios/EasyPilot-iOS-Extended.pptx
@@ -3189,7 +3189,7 @@
         <p:spPr>
           <a:xfrm>
             <a:off x="868680" y="1371600"/>
-            <a:ext cx="10058400" cy="457200"/>
+            <a:ext cx="10607040" cy="457200"/>
           </a:xfrm>
           <a:prstGeom prst="rect">
             <a:avLst/>
@@ -3214,13 +3214,13 @@
               </a:spcAft>
             </a:pPr>
             <a:r>
-              <a:rPr sz="1400" b="1">
+              <a:rPr sz="1600" b="1">
                 <a:solidFill>
                   <a:srgbClr val="2F80ED"/>
                 </a:solidFill>
                 <a:latin typeface="Segoe UI Semibold"/>
               </a:rPr>
-              <a:t>EASYPILOT  ·  4AHITM DROHNENPROJEKT</a:t>
+              <a:t>Das iPhone wird zur Anzeige- und Steuerzentrale für unsere Drohne.</a:t>
             </a:r>
           </a:p>
         </p:txBody>

</xml_diff>

<commit_message>
docs: drop title tagline, shorten slide-2 key statement
Remove the tagline from the title slide and change the slide-2 statement to
"iPhone wird zur Anzeige- und Steuerzentrale".

Co-Authored-By: Claude Opus 4.8 <noreply@anthropic.com>
</commit_message>
<xml_diff>
--- a/docs/presentation-ios/EasyPilot-iOS-Extended.pptx
+++ b/docs/presentation-ios/EasyPilot-iOS-Extended.pptx
@@ -3188,8 +3188,8 @@
         </p:nvSpPr>
         <p:spPr>
           <a:xfrm>
-            <a:off x="868680" y="1371600"/>
-            <a:ext cx="10607040" cy="457200"/>
+            <a:off x="822960" y="2057400"/>
+            <a:ext cx="10515600" cy="1371600"/>
           </a:xfrm>
           <a:prstGeom prst="rect">
             <a:avLst/>
@@ -3214,51 +3214,6 @@
               </a:spcAft>
             </a:pPr>
             <a:r>
-              <a:rPr sz="1600" b="1">
-                <a:solidFill>
-                  <a:srgbClr val="2F80ED"/>
-                </a:solidFill>
-                <a:latin typeface="Segoe UI Semibold"/>
-              </a:rPr>
-              <a:t>Das iPhone wird zur Anzeige- und Steuerzentrale für unsere Drohne.</a:t>
-            </a:r>
-          </a:p>
-        </p:txBody>
-      </p:sp>
-      <p:sp>
-        <p:nvSpPr>
-          <p:cNvPr id="5" name="TextBox 4"/>
-          <p:cNvSpPr txBox="1"/>
-          <p:nvPr/>
-        </p:nvSpPr>
-        <p:spPr>
-          <a:xfrm>
-            <a:off x="822960" y="2057400"/>
-            <a:ext cx="10515600" cy="1371600"/>
-          </a:xfrm>
-          <a:prstGeom prst="rect">
-            <a:avLst/>
-          </a:prstGeom>
-          <a:noFill/>
-        </p:spPr>
-        <p:txBody>
-          <a:bodyPr wrap="square" anchor="t" lIns="0" rIns="0" tIns="0" bIns="0">
-            <a:spAutoFit/>
-          </a:bodyPr>
-          <a:lstStyle/>
-          <a:p>
-            <a:pPr algn="l">
-              <a:lnSpc>
-                <a:spcPct val="100000"/>
-              </a:lnSpc>
-              <a:spcBef>
-                <a:spcPts val="0"/>
-              </a:spcBef>
-              <a:spcAft>
-                <a:spcPts val="800"/>
-              </a:spcAft>
-            </a:pPr>
-            <a:r>
               <a:rPr sz="6200" b="1">
                 <a:solidFill>
                   <a:srgbClr val="FFFFFF"/>
@@ -3281,7 +3236,7 @@
       </p:sp>
       <p:sp>
         <p:nvSpPr>
-          <p:cNvPr id="6" name="Rectangle 5"/>
+          <p:cNvPr id="5" name="Rectangle 4"/>
           <p:cNvSpPr/>
           <p:nvPr/>
         </p:nvSpPr>
@@ -3325,7 +3280,7 @@
       </p:sp>
       <p:sp>
         <p:nvSpPr>
-          <p:cNvPr id="7" name="TextBox 6"/>
+          <p:cNvPr id="6" name="TextBox 5"/>
           <p:cNvSpPr txBox="1"/>
           <p:nvPr/>
         </p:nvSpPr>
@@ -3392,7 +3347,7 @@
       </p:sp>
       <p:sp>
         <p:nvSpPr>
-          <p:cNvPr id="8" name="TextBox 7"/>
+          <p:cNvPr id="7" name="TextBox 6"/>
           <p:cNvSpPr txBox="1"/>
           <p:nvPr/>
         </p:nvSpPr>
@@ -4333,7 +4288,7 @@
                 </a:solidFill>
                 <a:latin typeface="Segoe UI Semibold"/>
               </a:rPr>
-              <a:t>Das iPhone wird zur Anzeige- und Steuerzentrale für unsere Drohne.</a:t>
+              <a:t>iPhone wird zur Anzeige- und Steuerzentrale</a:t>
             </a:r>
           </a:p>
         </p:txBody>

</xml_diff>